<commit_message>
Update RE PPT: version V1.4, integration into common tool
</commit_message>
<xml_diff>
--- a/JSW_PumpFlash_ReverseEngineering.pptx
+++ b/JSW_PumpFlash_ReverseEngineering.pptx
@@ -3357,7 +3357,7 @@
                   <a:srgbClr val="FFD700"/>
                 </a:solidFill>
               </a:rPr>
-              <a:t>JSW Air Pump  ✦  JSW Oil Pump  ✦  PEAK PCAN Hardware  ✦  Zero OEM Dependency</a:t>
+              <a:t>JSW Air Pump  ✦  JSW Oil Pump  ✦  PEAK PCAN Hardware  ✦  Integrated into JSW FlashXpert V1.4</a:t>
             </a:r>
           </a:p>
         </p:txBody>
@@ -3428,7 +3428,7 @@
               </a:rPr>
               <a:t>JSW
 FlashXpert
-V2.0</a:t>
+V1.4</a:t>
             </a:r>
           </a:p>
         </p:txBody>
@@ -4493,7 +4493,7 @@
                   <a:srgbClr val="FFFFFF"/>
                 </a:solidFill>
               </a:rPr>
-              <a:t>JSW FlashXpert  V2.0</a:t>
+              <a:t>JSW FlashXpert  V1.4</a:t>
             </a:r>
           </a:p>
         </p:txBody>
@@ -6113,7 +6113,7 @@
                   <a:srgbClr val="FFFFFF"/>
                 </a:solidFill>
               </a:rPr>
-              <a:t>JSW FlashXpert  V2.0</a:t>
+              <a:t>JSW FlashXpert  V1.4</a:t>
             </a:r>
           </a:p>
         </p:txBody>
@@ -7550,7 +7550,7 @@
                   <a:srgbClr val="FFFFFF"/>
                 </a:solidFill>
               </a:rPr>
-              <a:t>JSW FlashXpert  V2.0</a:t>
+              <a:t>JSW FlashXpert  V1.4</a:t>
             </a:r>
           </a:p>
         </p:txBody>
@@ -11576,7 +11576,7 @@
                   <a:srgbClr val="FFFFFF"/>
                 </a:solidFill>
               </a:rPr>
-              <a:t>JSW FlashXpert  V2.0</a:t>
+              <a:t>JSW FlashXpert  V1.4</a:t>
             </a:r>
           </a:p>
         </p:txBody>
@@ -12965,7 +12965,7 @@
                   <a:srgbClr val="FFFFFF"/>
                 </a:solidFill>
               </a:rPr>
-              <a:t>JSW FlashXpert  V2.0</a:t>
+              <a:t>JSW FlashXpert  V1.4</a:t>
             </a:r>
           </a:p>
         </p:txBody>
@@ -14678,7 +14678,7 @@
                   <a:srgbClr val="FFFFFF"/>
                 </a:solidFill>
               </a:rPr>
-              <a:t>JSW FlashXpert  V2.0</a:t>
+              <a:t>JSW FlashXpert  V1.4</a:t>
             </a:r>
           </a:p>
         </p:txBody>
@@ -14859,7 +14859,7 @@
                   <a:srgbClr val="FFFFFF"/>
                 </a:solidFill>
               </a:rPr>
-              <a:t>Integration into JSW FlashXpert</a:t>
+              <a:t>Integration into JSW FlashXpert V1.4 — Common Tool</a:t>
             </a:r>
           </a:p>
         </p:txBody>
@@ -14893,7 +14893,7 @@
                   <a:srgbClr val="93C5FD"/>
                 </a:solidFill>
               </a:rPr>
-              <a:t>From reverse-engineered protocol to production-ready flashing tool</a:t>
+              <a:t>Pump flashing added as a new tab in the same tool used for VCU, MCU, and all other ECUs</a:t>
             </a:r>
           </a:p>
         </p:txBody>
@@ -15015,7 +15015,7 @@
                   <a:srgbClr val="163C69"/>
                 </a:solidFill>
               </a:rPr>
-              <a:t>Software Architecture</a:t>
+              <a:t>Common Tool Architecture</a:t>
             </a:r>
           </a:p>
         </p:txBody>
@@ -15053,7 +15053,7 @@
                   <a:srgbClr val="111827"/>
                 </a:solidFill>
               </a:rPr>
-              <a:t>flashing_logic.py</a:t>
+              <a:t>JSW FlashXpert V1.4  (jsw_gui.py + flashing_logic.py)</a:t>
             </a:r>
           </a:p>
           <a:p>
@@ -15068,7 +15068,7 @@
                   <a:srgbClr val="111827"/>
                 </a:solidFill>
               </a:rPr>
-              <a:t>  ├─ CANBusWrapper       PEAK / Vector / Kvaser</a:t>
+              <a:t/>
             </a:r>
           </a:p>
           <a:p>
@@ -15083,7 +15083,7 @@
                   <a:srgbClr val="111827"/>
                 </a:solidFill>
               </a:rPr>
-              <a:t>  ├─ FlashingLogic       Existing UDS controllers</a:t>
+              <a:t>  ├─ CANBusWrapper       PEAK / Vector / Kvaser</a:t>
             </a:r>
           </a:p>
           <a:p>
@@ -15098,7 +15098,7 @@
                   <a:srgbClr val="111827"/>
                 </a:solidFill>
               </a:rPr>
-              <a:t>  ├─ PumpFlashingLogic   Oil Pump + Air Pump</a:t>
+              <a:t>  ├─ FlashingLogic       VCU / MCU (UDS / ISO-TP)</a:t>
             </a:r>
           </a:p>
           <a:p>
@@ -15113,7 +15113,7 @@
                   <a:srgbClr val="111827"/>
                 </a:solidFill>
               </a:rPr>
-              <a:t>  │    ├─ _pump_load_hex()         HEX parser</a:t>
+              <a:t>  ├─ PumpFlashingLogic   Oil Pump + Air Pump  ← NEW</a:t>
             </a:r>
           </a:p>
           <a:p>
@@ -15128,7 +15128,7 @@
                   <a:srgbClr val="111827"/>
                 </a:solidFill>
               </a:rPr>
-              <a:t>  │    ├─ _pump_build_oem_blocks() VER1 parser</a:t>
+              <a:t>  │    ├─ _pump_load_hex()         HEX parser</a:t>
             </a:r>
           </a:p>
           <a:p>
@@ -15143,7 +15143,7 @@
                   <a:srgbClr val="111827"/>
                 </a:solidFill>
               </a:rPr>
-              <a:t>  │    └─ _pump_build_blocks_sequential()</a:t>
+              <a:t>  │    ├─ _pump_build_oem_blocks() VER1 stride fix</a:t>
             </a:r>
           </a:p>
           <a:p>
@@ -15158,7 +15158,7 @@
                   <a:srgbClr val="111827"/>
                 </a:solidFill>
               </a:rPr>
-              <a:t>  └─ FOTAFlashingLogic   Phase 2 VCU FOTA</a:t>
+              <a:t>  │    └─ _pump_build_blocks_sequential()</a:t>
             </a:r>
           </a:p>
           <a:p>
@@ -15173,22 +15173,7 @@
                   <a:srgbClr val="111827"/>
                 </a:solidFill>
               </a:rPr>
-              <a:t/>
-            </a:r>
-          </a:p>
-          <a:p>
-            <a:pPr>
-              <a:spcBef>
-                <a:spcPts val="300"/>
-              </a:spcBef>
-            </a:pPr>
-            <a:r>
-              <a:rPr sz="1000">
-                <a:solidFill>
-                  <a:srgbClr val="111827"/>
-                </a:solidFill>
-              </a:rPr>
-              <a:t>jsw_gui.py  — unified GUI, Phase 1 + Phase 2 tabs</a:t>
+              <a:t>  └─ FOTAFlashingLogic   Phase 2 VCU FOTA  ← NEW</a:t>
             </a:r>
           </a:p>
         </p:txBody>
@@ -16344,7 +16329,7 @@
                   <a:srgbClr val="FFFFFF"/>
                 </a:solidFill>
               </a:rPr>
-              <a:t>JSW FlashXpert  V2.0</a:t>
+              <a:t>JSW FlashXpert  V1.4</a:t>
             </a:r>
           </a:p>
         </p:txBody>
@@ -16572,8 +16557,8 @@
         </p:nvSpPr>
         <p:spPr>
           <a:xfrm>
-            <a:off x="731520" y="2606040"/>
-            <a:ext cx="10972800" cy="914400"/>
+            <a:off x="731520" y="2514600"/>
+            <a:ext cx="10972800" cy="1097280"/>
           </a:xfrm>
           <a:prstGeom prst="rect">
             <a:avLst/>
@@ -16595,7 +16580,8 @@
               </a:rPr>
               <a:t>We reverse-engineered a proprietary CAN flash protocol from captured traffic alone,
 implemented it in Python using PEAK hardware we already own, auto-detect all firmware
-variants, handle live and cold-start ECUs — and shipped it as part of JSW FlashXpert.</a:t>
+variants, handle live and cold-start ECUs — integrated directly into JSW FlashXpert V1.4
+as a new tab alongside VCU/MCU flashing.  One tool.  All ECUs.  No OEM tools.</a:t>
             </a:r>
           </a:p>
         </p:txBody>
@@ -16663,7 +16649,7 @@
                   <a:srgbClr val="FFFFFF"/>
                 </a:solidFill>
               </a:rPr>
-              <a:t>JSW FlashXpert  V2.0</a:t>
+              <a:t>JSW FlashXpert  V1.4</a:t>
             </a:r>
           </a:p>
         </p:txBody>
@@ -16774,7 +16760,7 @@
                   <a:srgbClr val="FFFFFF"/>
                 </a:solidFill>
               </a:rPr>
-              <a:t>JSW FlashXpert  V2.0</a:t>
+              <a:t>JSW FlashXpert  V1.4</a:t>
             </a:r>
           </a:p>
         </p:txBody>

</xml_diff>